<commit_message>
PPT: apply the Evidence & Consistency Sheet corrections
Rebuilt the deck and PDF from the approved set (section C). Latency now
comes from T1 (E-63): 138 ms median and 196 ms p95, with first audio
18 ms after detection. Also updated:
- privacy wording: audio is sent only after a detection (true or false)
- openness: the closed Wi-Fi/PHY driver is disclosed
- false triggers: 15.8 /h; 15.1 -> 10.4 /h scoped to the same 52 min
- team ID and name
- hardware cost <= Rs 2,000 (team estimate)
- slide 3 technologies now give reasons
The team name in the oval no longer breaks mid-word.

Co-Authored-By: Claude Opus 5.5 <noreply@anthropic.com>
Original-commit: 9a6e7001b792279c0935fbfd50b8937d1f50b715
</commit_message>
<xml_diff>
--- a/docs/submission/PS26172_SIH2026_Idea.pptx
+++ b/docs/submission/PS26172_SIH2026_Idea.pptx
@@ -5980,7 +5980,7 @@
                 <a:latin typeface="Arial"/>
                 <a:cs typeface="Arial"/>
               </a:rPr>
-              <a:t>[Team ID]</a:t>
+              <a:t>AUC-SIH26-172041</a:t>
             </a:r>
           </a:p>
           <a:p>
@@ -6012,7 +6012,7 @@
                 <a:latin typeface="Arial"/>
                 <a:cs typeface="Arial"/>
               </a:rPr>
-              <a:t>[Team Name]</a:t>
+              <a:t>DATA_Edgepulse</a:t>
             </a:r>
           </a:p>
         </p:txBody>
@@ -6287,13 +6287,20 @@
           </a:fontRef>
         </p:style>
         <p:txBody>
-          <a:bodyPr rtlCol="0" anchor="ctr"/>
+          <a:bodyPr rtlCol="0" anchor="ctr" wrap="none" lIns="0" tIns="0" rIns="0" bIns="0"/>
           <a:lstStyle/>
           <a:p>
             <a:pPr algn="ctr"/>
             <a:r>
-              <a:rPr lang="en-US" dirty="0"/>
-              <a:t>[Team Name]</a:t>
+              <a:rPr lang="en-US" sz="1600" dirty="0"/>
+              <a:t>DATA_</a:t>
+            </a:r>
+            <a:br>
+              <a:rPr lang="en-US" sz="1600" dirty="0"/>
+            </a:br>
+            <a:r>
+              <a:rPr lang="en-US" sz="1600" dirty="0"/>
+              <a:t>Edgepulse</a:t>
             </a:r>
             <a:endParaRPr lang="en-IN" dirty="0"/>
           </a:p>
@@ -6468,7 +6475,7 @@
                 <a:latin typeface="Arial"/>
                 <a:cs typeface="Arial"/>
               </a:rPr>
-              <a:t>“Hey Vayro” detected (mean of 3 scores ≥ 0.70) → 571 ms pre-roll + live audio stream over one warm TCP link</a:t>
+              <a:t>“Hey Vayro” detected (mean of 3 scores ≥ 0.80) → 571 ms pre-roll + live audio stream over one warm TCP link</a:t>
             </a:r>
           </a:p>
           <a:p>
@@ -6551,7 +6558,7 @@
                 <a:latin typeface="Arial"/>
                 <a:cs typeface="Arial"/>
               </a:rPr>
-              <a:t>No audio leaves the device until the keyword is detected → privacy, zero cloud cost while idle</a:t>
+              <a:t>Audio leaves the device only after a detection (true or false) → privacy; nothing is sent or processed while idle</a:t>
             </a:r>
           </a:p>
           <a:p>
@@ -6570,7 +6577,7 @@
                 <a:latin typeface="Arial"/>
                 <a:cs typeface="Arial"/>
               </a:rPr>
-              <a:t>Inside the PS budget on real hardware: 245.6 KiB peak RAM, 4.7 % idle CPU</a:t>
+              <a:t>Inside the PS budget on real hardware: 245.0 KiB peak RAM, 5.5 % idle CPU</a:t>
             </a:r>
           </a:p>
           <a:p>
@@ -6589,7 +6596,7 @@
                 <a:latin typeface="Arial"/>
                 <a:cs typeface="Arial"/>
               </a:rPr>
-              <a:t>Low latency: first audio at the server ≈ 2 ms after detection; keyword end → server ≈ 95 ms</a:t>
+              <a:t>Low latency: keyword end → audio at the ASR server 138 ms median (196 ms p95), first audio 18 ms after detection</a:t>
             </a:r>
           </a:p>
           <a:p>
@@ -6608,7 +6615,7 @@
                 <a:latin typeface="Arial"/>
                 <a:cs typeface="Arial"/>
               </a:rPr>
-              <a:t>Only open-source components; custom keyword trained from scratch (no pre-trained wake word)</a:t>
+              <a:t>No proprietary voice SDK: keyword pipeline fully open source (only the Wi-Fi radio driver is closed, disclosed); keyword trained from scratch</a:t>
             </a:r>
           </a:p>
         </p:txBody>
@@ -6691,7 +6698,7 @@
                 <a:latin typeface="Arial"/>
                 <a:cs typeface="Arial"/>
               </a:rPr>
-              <a:t>Pre-roll ring buffer: a command spoken with no pause after the keyword is never clipped</a:t>
+              <a:t>Pre-roll: the stream starts 571 ms before the detection, so a command spoken right after the keyword is not cut off</a:t>
             </a:r>
           </a:p>
           <a:p>
@@ -6710,7 +6717,7 @@
                 <a:latin typeface="Arial"/>
                 <a:cs typeface="Arial"/>
               </a:rPr>
-              <a:t>Learns from real homes: its own logged false triggers become hard negatives (model v4)</a:t>
+              <a:t>The device logs every trigger with its score, so real-home false triggers can be mined for retraining</a:t>
             </a:r>
           </a:p>
           <a:p>
@@ -6729,7 +6736,7 @@
                 <a:latin typeface="Arial"/>
                 <a:cs typeface="Arial"/>
               </a:rPr>
-              <a:t>Each model is chosen by a rule written before testing; 58 logged evidence entries</a:t>
+              <a:t>Selection rules written before each held-out test (one documented override); 63 evidence entries</a:t>
             </a:r>
           </a:p>
         </p:txBody>
@@ -6841,7 +6848,7 @@
                 <a:latin typeface="Arial"/>
                 <a:cs typeface="Arial"/>
               </a:rPr>
-              <a:t>245.6 KiB</a:t>
+              <a:t>245.0 KiB</a:t>
             </a:r>
           </a:p>
           <a:p>
@@ -6906,7 +6913,7 @@
                 <a:latin typeface="Arial"/>
                 <a:cs typeface="Arial"/>
               </a:rPr>
-              <a:t>4.7 %</a:t>
+              <a:t>5.5 %</a:t>
             </a:r>
           </a:p>
           <a:p>
@@ -6924,7 +6931,7 @@
                 <a:latin typeface="Arial"/>
                 <a:cs typeface="Arial"/>
               </a:rPr>
-              <a:t>idle CPU, both cores (busiest core 8.8 %)</a:t>
+              <a:t>idle CPU, both cores (busiest core 9.5 %)</a:t>
             </a:r>
           </a:p>
         </p:txBody>
@@ -6971,7 +6978,7 @@
                 <a:latin typeface="Arial"/>
                 <a:cs typeface="Arial"/>
               </a:rPr>
-              <a:t>≈ 95 ms</a:t>
+              <a:t>138 ms</a:t>
             </a:r>
           </a:p>
           <a:p>
@@ -6989,7 +6996,7 @@
                 <a:latin typeface="Arial"/>
                 <a:cs typeface="Arial"/>
               </a:rPr>
-              <a:t>keyword end → server (median)</a:t>
+              <a:t>keyword end → ASR server (median)</a:t>
             </a:r>
           </a:p>
         </p:txBody>
@@ -7220,13 +7227,20 @@
           </a:fontRef>
         </p:style>
         <p:txBody>
-          <a:bodyPr rtlCol="0" anchor="ctr"/>
+          <a:bodyPr rtlCol="0" anchor="ctr" wrap="none" lIns="0" tIns="0" rIns="0" bIns="0"/>
           <a:lstStyle/>
           <a:p>
             <a:pPr algn="ctr"/>
             <a:r>
-              <a:rPr lang="en-US" dirty="0"/>
-              <a:t>[Team Name]</a:t>
+              <a:rPr lang="en-US" sz="1600" dirty="0"/>
+              <a:t>DATA_</a:t>
+            </a:r>
+            <a:br>
+              <a:rPr lang="en-US" sz="1600" dirty="0"/>
+            </a:br>
+            <a:r>
+              <a:rPr lang="en-US" sz="1600" dirty="0"/>
+              <a:t>Edgepulse</a:t>
             </a:r>
             <a:endParaRPr lang="en-IN" dirty="0"/>
           </a:p>
@@ -7312,7 +7326,7 @@
               <a:buChar char="•"/>
             </a:pPr>
             <a:r>
-              <a:rPr lang="en-US" sz="1200" b="1" i="0" dirty="0">
+              <a:rPr lang="en-US" sz="1100" b="1" i="0" dirty="0">
                 <a:solidFill>
                   <a:srgbClr val="1A1A1A"/>
                 </a:solidFill>
@@ -7322,26 +7336,26 @@
               <a:t xml:space="preserve">Hardware: </a:t>
             </a:r>
             <a:r>
-              <a:rPr lang="en-US" sz="1200" b="0" i="0" dirty="0">
+              <a:rPr lang="en-US" sz="1100" b="0" i="0" dirty="0">
                 <a:solidFill>
                   <a:srgbClr val="1A1A1A"/>
                 </a:solidFill>
                 <a:latin typeface="Arial"/>
                 <a:cs typeface="Arial"/>
               </a:rPr>
-              <a:t>ESP32-S3 N16R8 (240 MHz, PSRAM off) + INMP441 I2S MEMS mic</a:t>
+              <a:t>ESP32-S3 N16R8 — 240 MHz dual core, SIMD used by ESP-NN, on-chip Wi-Fi (PSRAM off); INMP441 — digital I2S mic, no analog stage</a:t>
             </a:r>
           </a:p>
           <a:p>
             <a:pPr algn="l" marL="146304" indent="-146304">
               <a:spcBef>
-                <a:spcPts val="700"/>
+                <a:spcPts val="600"/>
               </a:spcBef>
               <a:buFont typeface="Arial"/>
               <a:buChar char="•"/>
             </a:pPr>
             <a:r>
-              <a:rPr lang="en-US" sz="1200" b="1" i="0" dirty="0">
+              <a:rPr lang="en-US" sz="1100" b="1" i="0" dirty="0">
                 <a:solidFill>
                   <a:srgbClr val="1A1A1A"/>
                 </a:solidFill>
@@ -7351,26 +7365,26 @@
               <a:t xml:space="preserve">Firmware: </a:t>
             </a:r>
             <a:r>
-              <a:rPr lang="en-US" sz="1200" b="0" i="0" dirty="0">
+              <a:rPr lang="en-US" sz="1100" b="0" i="0" dirty="0">
                 <a:solidFill>
                   <a:srgbClr val="1A1A1A"/>
                 </a:solidFill>
                 <a:latin typeface="Arial"/>
                 <a:cs typeface="Arial"/>
               </a:rPr>
-              <a:t>C / C++ on ESP-IDF 5.5.5 (FreeRTOS)</a:t>
+              <a:t>C / C++ on ESP-IDF 5.5.5 (FreeRTOS) — open source, vendor-supported</a:t>
             </a:r>
           </a:p>
           <a:p>
             <a:pPr algn="l" marL="146304" indent="-146304">
               <a:spcBef>
-                <a:spcPts val="700"/>
+                <a:spcPts val="600"/>
               </a:spcBef>
               <a:buFont typeface="Arial"/>
               <a:buChar char="•"/>
             </a:pPr>
             <a:r>
-              <a:rPr lang="en-US" sz="1200" b="1" i="0" dirty="0">
+              <a:rPr lang="en-US" sz="1100" b="1" i="0" dirty="0">
                 <a:solidFill>
                   <a:srgbClr val="1A1A1A"/>
                 </a:solidFill>
@@ -7380,101 +7394,130 @@
               <a:t xml:space="preserve">TinyML: </a:t>
             </a:r>
             <a:r>
-              <a:rPr lang="en-US" sz="1200" b="0" i="0" dirty="0">
+              <a:rPr lang="en-US" sz="1100" b="0" i="0" dirty="0">
                 <a:solidFill>
                   <a:srgbClr val="1A1A1A"/>
                 </a:solidFill>
                 <a:latin typeface="Arial"/>
                 <a:cs typeface="Arial"/>
               </a:rPr>
-              <a:t>TensorFlow Lite Micro + ESP-NN kernels, TFLM microfrontend</a:t>
+              <a:t>TensorFlow Lite Micro + ESP-NN, TFLM microfrontend — integer inference, no OS needed</a:t>
             </a:r>
           </a:p>
           <a:p>
             <a:pPr algn="l" marL="146304" indent="-146304">
               <a:spcBef>
-                <a:spcPts val="700"/>
+                <a:spcPts val="600"/>
               </a:spcBef>
               <a:buFont typeface="Arial"/>
               <a:buChar char="•"/>
             </a:pPr>
             <a:r>
-              <a:rPr lang="en-US" sz="1200" b="1" i="0" dirty="0">
+              <a:rPr lang="en-US" sz="1100" b="1" i="0" dirty="0">
                 <a:solidFill>
                   <a:srgbClr val="1A1A1A"/>
                 </a:solidFill>
                 <a:latin typeface="Arial"/>
                 <a:cs typeface="Arial"/>
               </a:rPr>
-              <a:t xml:space="preserve">Training: </a:t>
-            </a:r>
-            <a:r>
-              <a:rPr lang="en-US" sz="1200" b="0" i="0" dirty="0">
+              <a:t xml:space="preserve">Model: </a:t>
+            </a:r>
+            <a:r>
+              <a:rPr lang="en-US" sz="1100" b="0" i="0" dirty="0">
                 <a:solidFill>
                   <a:srgbClr val="1A1A1A"/>
                 </a:solidFill>
                 <a:latin typeface="Arial"/>
                 <a:cs typeface="Arial"/>
               </a:rPr>
-              <a:t>Python, TensorFlow / Keras, Piper TTS (4 voices), LibriSpeech, our own recordings</a:t>
+              <a:t>DS-CNN — small and accurate for keyword spotting on MCUs [1]</a:t>
             </a:r>
           </a:p>
           <a:p>
             <a:pPr algn="l" marL="146304" indent="-146304">
               <a:spcBef>
-                <a:spcPts val="700"/>
+                <a:spcPts val="600"/>
               </a:spcBef>
               <a:buFont typeface="Arial"/>
               <a:buChar char="•"/>
             </a:pPr>
             <a:r>
-              <a:rPr lang="en-US" sz="1200" b="1" i="0" dirty="0">
+              <a:rPr lang="en-US" sz="1100" b="1" i="0" dirty="0">
                 <a:solidFill>
                   <a:srgbClr val="1A1A1A"/>
                 </a:solidFill>
                 <a:latin typeface="Arial"/>
                 <a:cs typeface="Arial"/>
               </a:rPr>
-              <a:t xml:space="preserve">Server: </a:t>
-            </a:r>
-            <a:r>
-              <a:rPr lang="en-US" sz="1200" b="0" i="0" dirty="0">
+              <a:t xml:space="preserve">Training: </a:t>
+            </a:r>
+            <a:r>
+              <a:rPr lang="en-US" sz="1100" b="0" i="0" dirty="0">
                 <a:solidFill>
                   <a:srgbClr val="1A1A1A"/>
                 </a:solidFill>
                 <a:latin typeface="Arial"/>
                 <a:cs typeface="Arial"/>
               </a:rPr>
-              <a:t>Python TCP ingest, energy VAD, Vosk / Kaldi ASR</a:t>
+              <a:t>Python, TensorFlow / Keras, Piper TTS (4 voices), LibriSpeech, our own recordings</a:t>
             </a:r>
           </a:p>
           <a:p>
             <a:pPr algn="l" marL="146304" indent="-146304">
               <a:spcBef>
-                <a:spcPts val="700"/>
+                <a:spcPts val="600"/>
               </a:spcBef>
               <a:buFont typeface="Arial"/>
               <a:buChar char="•"/>
             </a:pPr>
             <a:r>
-              <a:rPr lang="en-US" sz="1200" b="1" i="0" dirty="0">
+              <a:rPr lang="en-US" sz="1100" b="1" i="0" dirty="0">
                 <a:solidFill>
                   <a:srgbClr val="1A1A1A"/>
                 </a:solidFill>
                 <a:latin typeface="Arial"/>
                 <a:cs typeface="Arial"/>
               </a:rPr>
+              <a:t xml:space="preserve">Server: </a:t>
+            </a:r>
+            <a:r>
+              <a:rPr lang="en-US" sz="1100" b="0" i="0" dirty="0">
+                <a:solidFill>
+                  <a:srgbClr val="1A1A1A"/>
+                </a:solidFill>
+                <a:latin typeface="Arial"/>
+                <a:cs typeface="Arial"/>
+              </a:rPr>
+              <a:t>Python ingest, energy VAD, Vosk / Kaldi — open, offline, not a transformer</a:t>
+            </a:r>
+          </a:p>
+          <a:p>
+            <a:pPr algn="l" marL="146304" indent="-146304">
+              <a:spcBef>
+                <a:spcPts val="600"/>
+              </a:spcBef>
+              <a:buFont typeface="Arial"/>
+              <a:buChar char="•"/>
+            </a:pPr>
+            <a:r>
+              <a:rPr lang="en-US" sz="1100" b="1" i="0" dirty="0">
+                <a:solidFill>
+                  <a:srgbClr val="1A1A1A"/>
+                </a:solidFill>
+                <a:latin typeface="Arial"/>
+                <a:cs typeface="Arial"/>
+              </a:rPr>
               <a:t xml:space="preserve">Verification: </a:t>
             </a:r>
             <a:r>
-              <a:rPr lang="en-US" sz="1200" b="0" i="0" dirty="0">
+              <a:rPr lang="en-US" sz="1100" b="0" i="0" dirty="0">
                 <a:solidFill>
                   <a:srgbClr val="1A1A1A"/>
                 </a:solidFill>
                 <a:latin typeface="Arial"/>
                 <a:cs typeface="Arial"/>
               </a:rPr>
-              <a:t>bit-exact host twin of the front end, scripted capture and replay tools</a:t>
+              <a:t>bit-exact host twin of the front end, scripted capture and replay</a:t>
             </a:r>
           </a:p>
         </p:txBody>
@@ -7902,7 +7945,7 @@
                 <a:latin typeface="Arial"/>
                 <a:cs typeface="Arial"/>
               </a:rPr>
-              <a:t>mean of 3 ≥ 0.70, 2 s refractory</a:t>
+              <a:t>mean of 3 ≥ 0.80, 2 s refractory</a:t>
             </a:r>
           </a:p>
         </p:txBody>
@@ -8907,7 +8950,7 @@
                 <a:latin typeface="Arial"/>
                 <a:cs typeface="Arial"/>
               </a:rPr>
-              <a:t>ESP32-S3-N16R8 + INMP441 on a breadboard (SCK→GPIO6, WS→GPIO5, SD→GPIO4). The demo video shows keyword → stream → transcript live on this board.</a:t>
+              <a:t>ESP32-S3-N16R8 + INMP441 (SCK→GPIO6, WS→GPIO5, SD→GPIO4). The demo video shows keyword → stream → transcript live on this board.</a:t>
             </a:r>
           </a:p>
           <a:p>
@@ -9264,13 +9307,20 @@
           </a:fontRef>
         </p:style>
         <p:txBody>
-          <a:bodyPr rtlCol="0" anchor="ctr"/>
+          <a:bodyPr rtlCol="0" anchor="ctr" wrap="none" lIns="0" tIns="0" rIns="0" bIns="0"/>
           <a:lstStyle/>
           <a:p>
             <a:pPr algn="ctr"/>
             <a:r>
-              <a:rPr lang="en-US" dirty="0"/>
-              <a:t>[Team Name]</a:t>
+              <a:rPr lang="en-US" sz="1600" dirty="0"/>
+              <a:t>DATA_</a:t>
+            </a:r>
+            <a:br>
+              <a:rPr lang="en-US" sz="1600" dirty="0"/>
+            </a:br>
+            <a:r>
+              <a:rPr lang="en-US" sz="1600" dirty="0"/>
+              <a:t>Edgepulse</a:t>
             </a:r>
             <a:endParaRPr lang="en-IN" dirty="0"/>
           </a:p>
@@ -9431,7 +9481,7 @@
                 <a:latin typeface="Arial"/>
                 <a:cs typeface="Arial"/>
               </a:rPr>
-              <a:t>245.6 KiB</a:t>
+              <a:t>245.0 KiB</a:t>
             </a:r>
           </a:p>
           <a:p>
@@ -9496,7 +9546,7 @@
                 <a:latin typeface="Arial"/>
                 <a:cs typeface="Arial"/>
               </a:rPr>
-              <a:t>4.7 %</a:t>
+              <a:t>5.5 %</a:t>
             </a:r>
           </a:p>
           <a:p>
@@ -9514,7 +9564,7 @@
                 <a:latin typeface="Arial"/>
                 <a:cs typeface="Arial"/>
               </a:rPr>
-              <a:t>idle CPU, 2 cores (max core 8.8 %)</a:t>
+              <a:t>idle CPU, 2 cores (max core 9.5 %)</a:t>
             </a:r>
           </a:p>
         </p:txBody>
@@ -9620,7 +9670,7 @@
                 <a:latin typeface="Arial"/>
                 <a:cs typeface="Arial"/>
               </a:rPr>
-              <a:t>Accuracy (model v4)</a:t>
+              <a:t>Accuracy (shipped model v2b)</a:t>
             </a:r>
           </a:p>
         </p:txBody>
@@ -9667,7 +9717,7 @@
                 <a:latin typeface="Arial"/>
                 <a:cs typeface="Arial"/>
               </a:rPr>
-              <a:t>21 / 25</a:t>
+              <a:t>22 / 25</a:t>
             </a:r>
           </a:p>
           <a:p>
@@ -9685,7 +9735,7 @@
                 <a:latin typeface="Arial"/>
                 <a:cs typeface="Arial"/>
               </a:rPr>
-              <a:t>held-out keyword prompts, 0.5–2 m</a:t>
+              <a:t>speaker 1, held-out session, 0.5–2 m</a:t>
             </a:r>
           </a:p>
         </p:txBody>
@@ -9732,7 +9782,7 @@
                 <a:latin typeface="Arial"/>
                 <a:cs typeface="Arial"/>
               </a:rPr>
-              <a:t>10 / 10</a:t>
+              <a:t>20 / 25</a:t>
             </a:r>
           </a:p>
           <a:p>
@@ -9750,7 +9800,7 @@
                 <a:latin typeface="Arial"/>
                 <a:cs typeface="Arial"/>
               </a:rPr>
-              <a:t>fresh keyword + command prompts</a:t>
+              <a:t>new speaker, never trained on</a:t>
             </a:r>
           </a:p>
         </p:txBody>
@@ -9797,7 +9847,7 @@
                 <a:latin typeface="Arial"/>
                 <a:cs typeface="Arial"/>
               </a:rPr>
-              <a:t>0 in 5 h</a:t>
+              <a:t>0.2 · 15.8</a:t>
             </a:r>
           </a:p>
           <a:p>
@@ -9815,7 +9865,7 @@
                 <a:latin typeface="Arial"/>
                 <a:cs typeface="Arial"/>
               </a:rPr>
-              <a:t>false triggers, quiet night (held-out)</a:t>
+              <a:t>false triggers per hour: quiet · TV/talk</a:t>
             </a:r>
           </a:p>
         </p:txBody>
@@ -9856,7 +9906,7 @@
                 <a:latin typeface="Arial"/>
                 <a:cs typeface="Arial"/>
               </a:rPr>
-              <a:t>Latency</a:t>
+              <a:t>Latency (final firmware, ASR on)</a:t>
             </a:r>
           </a:p>
         </p:txBody>
@@ -9903,7 +9953,7 @@
                 <a:latin typeface="Arial"/>
                 <a:cs typeface="Arial"/>
               </a:rPr>
-              <a:t>1.7 ms</a:t>
+              <a:t>138 ms</a:t>
             </a:r>
           </a:p>
           <a:p>
@@ -9921,7 +9971,7 @@
                 <a:latin typeface="Arial"/>
                 <a:cs typeface="Arial"/>
               </a:rPr>
-              <a:t>detection → first packet at server</a:t>
+              <a:t>keyword end → ASR server (median)</a:t>
             </a:r>
           </a:p>
         </p:txBody>
@@ -9968,7 +10018,7 @@
                 <a:latin typeface="Arial"/>
                 <a:cs typeface="Arial"/>
               </a:rPr>
-              <a:t>≈ 95 ms</a:t>
+              <a:t>196 ms</a:t>
             </a:r>
           </a:p>
           <a:p>
@@ -9986,7 +10036,7 @@
                 <a:latin typeface="Arial"/>
                 <a:cs typeface="Arial"/>
               </a:rPr>
-              <a:t>keyword end → server (median)</a:t>
+              <a:t>keyword end → ASR server (p95)</a:t>
             </a:r>
           </a:p>
         </p:txBody>
@@ -10033,7 +10083,7 @@
                 <a:latin typeface="Arial"/>
                 <a:cs typeface="Arial"/>
               </a:rPr>
-              <a:t>136 ms</a:t>
+              <a:t>18 ms</a:t>
             </a:r>
           </a:p>
           <a:p>
@@ -10051,7 +10101,7 @@
                 <a:latin typeface="Arial"/>
                 <a:cs typeface="Arial"/>
               </a:rPr>
-              <a:t>keyword end → server (p95)</a:t>
+              <a:t>detection → first audio (median)</a:t>
             </a:r>
           </a:p>
         </p:txBody>
@@ -10184,7 +10234,7 @@
                 <a:latin typeface="Arial"/>
                 <a:cs typeface="Arial"/>
               </a:rPr>
-              <a:t>TV / family speech still triggers: 10.4 per hour (held-out household audio)</a:t>
+              <a:t>TV / family speech still triggers: 15.8 per hour (2.5 h of held-out household audio)</a:t>
             </a:r>
           </a:p>
         </p:txBody>
@@ -10229,7 +10279,7 @@
                 <a:latin typeface="Arial"/>
                 <a:cs typeface="Arial"/>
               </a:rPr>
-              <a:t>Hard negatives mined from the device’s own false triggers already cut 15.1 → 10.4 /h; next: more household hours, server-side second check that drops streams with no command</a:t>
+              <a:t>On the same 52 min, retraining with the device’s own false triggers cut 15.1 → 10.4 /h (v4), but v4 lost new-speaker recall (14/25), so v2b ships; next: more speakers + household audio together</a:t>
             </a:r>
           </a:p>
         </p:txBody>
@@ -10274,7 +10324,7 @@
                 <a:latin typeface="Arial"/>
                 <a:cs typeface="Arial"/>
               </a:rPr>
-              <a:t>Real-voice testing so far: one main speaker (plus TTS voices in 4 accents)</a:t>
+              <a:t>Real voices tested so far: two speakers (plus 4 TTS voices: US, UK, non-native, Hindi)</a:t>
             </a:r>
           </a:p>
         </p:txBody>
@@ -10833,13 +10883,20 @@
           </a:fontRef>
         </p:style>
         <p:txBody>
-          <a:bodyPr rtlCol="0" anchor="ctr"/>
+          <a:bodyPr rtlCol="0" anchor="ctr" wrap="none" lIns="0" tIns="0" rIns="0" bIns="0"/>
           <a:lstStyle/>
           <a:p>
             <a:pPr algn="ctr"/>
             <a:r>
-              <a:rPr lang="en-US" dirty="0"/>
-              <a:t>[Team Name]</a:t>
+              <a:rPr lang="en-US" sz="1600" dirty="0"/>
+              <a:t>DATA_</a:t>
+            </a:r>
+            <a:br>
+              <a:rPr lang="en-US" sz="1600" dirty="0"/>
+            </a:br>
+            <a:r>
+              <a:rPr lang="en-US" sz="1600" dirty="0"/>
+              <a:t>Edgepulse</a:t>
             </a:r>
             <a:endParaRPr lang="en-IN" dirty="0"/>
           </a:p>
@@ -10974,7 +11031,7 @@
                 <a:latin typeface="Arial"/>
                 <a:cs typeface="Arial"/>
               </a:rPr>
-              <a:t>a ready wake-word front end for any ESP32-class home, office or factory device</a:t>
+              <a:t>a ready wake-word front end for ESP32-S3 home, office or factory devices</a:t>
             </a:r>
           </a:p>
           <a:p>
@@ -11032,7 +11089,7 @@
                 <a:latin typeface="Arial"/>
                 <a:cs typeface="Arial"/>
               </a:rPr>
-              <a:t>custom keyword with Indian-accent training data, no vendor SDK or licence fee</a:t>
+              <a:t>custom keyword with Indian-accent training data and no vendor voice SDK</a:t>
             </a:r>
           </a:p>
         </p:txBody>
@@ -11097,7 +11154,7 @@
                 <a:latin typeface="Arial"/>
                 <a:cs typeface="Arial"/>
               </a:rPr>
-              <a:t>of audio sent until the keyword is detected</a:t>
+              <a:t>of audio sent before a detection</a:t>
             </a:r>
           </a:p>
         </p:txBody>
@@ -11270,7 +11327,7 @@
                 <a:latin typeface="Arial"/>
                 <a:cs typeface="Arial"/>
               </a:rPr>
-              <a:t>Privacy by design: the room is only heard by the chip until someone says “Hey Vayro”</a:t>
+              <a:t>Privacy by design: audio leaves the chip only after a detection (true or false); nothing is sent while idle</a:t>
             </a:r>
           </a:p>
         </p:txBody>
@@ -11336,7 +11393,7 @@
                 <a:latin typeface="Arial"/>
                 <a:cs typeface="Arial"/>
               </a:rPr>
-              <a:t>Hardware ≈ ₹1 000 (estimate); open-source stack; no cloud cost while listening</a:t>
+              <a:t>Hardware ≤ ₹2,000 (team estimate); open-source stack; no audio processed in the cloud while idle</a:t>
             </a:r>
           </a:p>
         </p:txBody>
@@ -11402,7 +11459,7 @@
                 <a:latin typeface="Arial"/>
                 <a:cs typeface="Arial"/>
               </a:rPr>
-              <a:t>Low compute (4.7 % CPU idle); audio is sent only after the keyword, so traffic stays tiny. Wi-Fi is kept awake for latency; power not yet measured</a:t>
+              <a:t>Low compute (5.5 % CPU idle); audio is sent only after a detection, so traffic stays tiny. Wi-Fi is kept awake for latency; power not yet measured</a:t>
             </a:r>
           </a:p>
         </p:txBody>
@@ -11468,7 +11525,7 @@
                 <a:latin typeface="Arial"/>
                 <a:cs typeface="Arial"/>
               </a:rPr>
-              <a:t>Reproducible: a new keyword = new recordings + the same scripts; every number traceable to an evidence log</a:t>
+              <a:t>Reproducible: data, training, selection and tests are scripts; every number is traceable to an evidence log</a:t>
             </a:r>
           </a:p>
         </p:txBody>
@@ -11802,13 +11859,20 @@
           </a:fontRef>
         </p:style>
         <p:txBody>
-          <a:bodyPr rtlCol="0" anchor="ctr"/>
+          <a:bodyPr rtlCol="0" anchor="ctr" wrap="none" lIns="0" tIns="0" rIns="0" bIns="0"/>
           <a:lstStyle/>
           <a:p>
             <a:pPr algn="ctr"/>
             <a:r>
-              <a:rPr lang="en-US" dirty="0"/>
-              <a:t>[Team Name]</a:t>
+              <a:rPr lang="en-US" sz="1600" dirty="0"/>
+              <a:t>DATA_</a:t>
+            </a:r>
+            <a:br>
+              <a:rPr lang="en-US" sz="1600" dirty="0"/>
+            </a:br>
+            <a:r>
+              <a:rPr lang="en-US" sz="1600" dirty="0"/>
+              <a:t>Edgepulse</a:t>
             </a:r>
             <a:endParaRPr lang="en-IN" dirty="0"/>
           </a:p>
@@ -12324,7 +12388,7 @@
                 <a:latin typeface="Arial"/>
                 <a:cs typeface="Arial"/>
               </a:rPr>
-              <a:t>58 entries, each tagged measured / estimated / proposed, with its raw data</a:t>
+              <a:t>63 entries, each tagged measured / estimated / proposed and pointing to its raw data</a:t>
             </a:r>
           </a:p>
           <a:p>
@@ -12353,7 +12417,7 @@
                 <a:latin typeface="Arial"/>
                 <a:cs typeface="Arial"/>
               </a:rPr>
-              <a:t>written and committed before each held-out test</a:t>
+              <a:t>written and committed before each held-out test; one documented override (new-speaker evidence)</a:t>
             </a:r>
           </a:p>
           <a:p>
@@ -12382,7 +12446,7 @@
                 <a:latin typeface="Arial"/>
                 <a:cs typeface="Arial"/>
               </a:rPr>
-              <a:t>every component and licence listed; the one closed Wi-Fi radio blob and the non-commercial TTS voices are disclosed</a:t>
+              <a:t>every component and licence listed; the closed Wi-Fi/PHY radio driver and two non-commercial TTS voices are disclosed</a:t>
             </a:r>
           </a:p>
           <a:p>

</xml_diff>